<commit_message>
feat: Update sf-develop skill references and enhance documentation across multiple files
</commit_message>
<xml_diff>
--- a/reference/salesforce-consulting-frameworkV2.pptx
+++ b/reference/salesforce-consulting-frameworkV2.pptx
@@ -3702,7 +3702,7 @@
                 <a:ea typeface="Calibri" pitchFamily="34" charset="-122"/>
                 <a:cs typeface="Calibri" pitchFamily="34" charset="-120"/>
               </a:rPr>
-              <a:t>2 Claude Code Skills  |  16 Golden Rules  |  8 Interview Rounds  |  4 Entry Points</a:t>
+              <a:t>3 Claude Code Skills  |  16 Golden Rules  |  8 Interview Rounds  |  4 Entry Points</a:t>
             </a:r>
             <a:endParaRPr lang="en-US" sz="1400" dirty="0">
               <a:solidFill>
@@ -6963,7 +6963,7 @@
                 <a:ea typeface="Calibri" pitchFamily="34" charset="-122"/>
                 <a:cs typeface="Calibri" pitchFamily="34" charset="-120"/>
               </a:rPr>
-              <a:t>Begin</a:t>
+              <a:t>Begin Build</a:t>
             </a:r>
             <a:endParaRPr lang="en-US" sz="1100" dirty="0"/>
           </a:p>
@@ -6972,7 +6972,7 @@
               <a:buNone/>
             </a:pPr>
             <a:r>
-              <a:rPr lang="en-US" sz="1100" b="1" dirty="0">
+              <a:rPr lang="en-US" sz="900" dirty="0">
                 <a:solidFill>
                   <a:srgbClr val="FFFFFF"/>
                 </a:solidFill>
@@ -6980,7 +6980,7 @@
                 <a:ea typeface="Calibri" pitchFamily="34" charset="-122"/>
                 <a:cs typeface="Calibri" pitchFamily="34" charset="-120"/>
               </a:rPr>
-              <a:t>Build</a:t>
+              <a:t>(sf-develop)</a:t>
             </a:r>
             <a:endParaRPr lang="en-US" sz="1100" dirty="0"/>
           </a:p>
@@ -7932,7 +7932,7 @@
                 <a:ea typeface="Calibri" pitchFamily="34" charset="-122"/>
                 <a:cs typeface="Calibri" pitchFamily="34" charset="-120"/>
               </a:rPr>
-              <a:t>Also generated: </a:t>
+              <a:t xml:space="preserve">Also generated: </a:t>
             </a:r>
             <a:r>
               <a:rPr lang="en-US" sz="1000" dirty="0">
@@ -10746,7 +10746,7 @@
                 <a:ea typeface="Georgia" pitchFamily="34" charset="-122"/>
                 <a:cs typeface="Georgia" pitchFamily="34" charset="-120"/>
               </a:rPr>
-              <a:t>+ 2 Skills</a:t>
+              <a:t>+ 3 Skills</a:t>
             </a:r>
             <a:endParaRPr lang="en-US" sz="1300" dirty="0"/>
           </a:p>
@@ -15450,7 +15450,7 @@
                 <a:ea typeface="Calibri" pitchFamily="34" charset="-122"/>
                 <a:cs typeface="Calibri" pitchFamily="34" charset="-120"/>
               </a:rPr>
-              <a:t>Sprint dev</a:t>
+              <a:t>Sprint dev via</a:t>
             </a:r>
             <a:endParaRPr lang="en-US" sz="800" dirty="0"/>
           </a:p>
@@ -15459,6 +15459,23 @@
               <a:buNone/>
             </a:pPr>
             <a:r>
+              <a:rPr lang="en-US" sz="800" b="1" dirty="0">
+                <a:solidFill>
+                  <a:srgbClr val="0D9488"/>
+                </a:solidFill>
+                <a:latin typeface="Calibri" pitchFamily="34" charset="0"/>
+                <a:ea typeface="Calibri" pitchFamily="34" charset="-122"/>
+                <a:cs typeface="Calibri" pitchFamily="34" charset="-120"/>
+              </a:rPr>
+              <a:t>sf-develop</a:t>
+            </a:r>
+            <a:endParaRPr lang="en-US" sz="800" dirty="0"/>
+          </a:p>
+          <a:p>
+            <a:pPr marL="0" indent="0" algn="ctr">
+              <a:buNone/>
+            </a:pPr>
+            <a:r>
               <a:rPr lang="en-US" sz="800" dirty="0">
                 <a:solidFill>
                   <a:srgbClr val="1E293B"/>
@@ -15467,24 +15484,7 @@
                 <a:ea typeface="Calibri" pitchFamily="34" charset="-122"/>
                 <a:cs typeface="Calibri" pitchFamily="34" charset="-120"/>
               </a:rPr>
-              <a:t>configuration</a:t>
-            </a:r>
-            <a:endParaRPr lang="en-US" sz="800" dirty="0"/>
-          </a:p>
-          <a:p>
-            <a:pPr marL="0" indent="0" algn="ctr">
-              <a:buNone/>
-            </a:pPr>
-            <a:r>
-              <a:rPr lang="en-US" sz="800" dirty="0">
-                <a:solidFill>
-                  <a:srgbClr val="1E293B"/>
-                </a:solidFill>
-                <a:latin typeface="Calibri" pitchFamily="34" charset="0"/>
-                <a:ea typeface="Calibri" pitchFamily="34" charset="-122"/>
-                <a:cs typeface="Calibri" pitchFamily="34" charset="-120"/>
-              </a:rPr>
-              <a:t>customization</a:t>
+              <a:t>config &amp; custom</a:t>
             </a:r>
             <a:endParaRPr lang="en-US" sz="800" dirty="0"/>
           </a:p>
@@ -16734,7 +16734,7 @@
                 <a:ea typeface="Georgia" pitchFamily="34" charset="-122"/>
                 <a:cs typeface="Georgia" pitchFamily="34" charset="-120"/>
               </a:rPr>
-              <a:t>2 AI Skills</a:t>
+              <a:t>3 AI Skills</a:t>
             </a:r>
             <a:endParaRPr lang="en-US" sz="1400" dirty="0"/>
           </a:p>
@@ -16773,7 +16773,7 @@
                 <a:ea typeface="Calibri" pitchFamily="34" charset="-122"/>
                 <a:cs typeface="Calibri" pitchFamily="34" charset="-120"/>
               </a:rPr>
-              <a:t>sf-project-init &amp;</a:t>
+              <a:t>sf-project-init</a:t>
             </a:r>
             <a:endParaRPr lang="en-US" sz="1100" dirty="0"/>
           </a:p>
@@ -16791,6 +16791,23 @@
                 <a:cs typeface="Calibri" pitchFamily="34" charset="-120"/>
               </a:rPr>
               <a:t>sf-architect-solutioning</a:t>
+            </a:r>
+            <a:endParaRPr lang="en-US" sz="1100" dirty="0"/>
+          </a:p>
+          <a:p>
+            <a:pPr marL="0" indent="0" algn="ctr">
+              <a:buNone/>
+            </a:pPr>
+            <a:r>
+              <a:rPr lang="en-US" sz="1100" dirty="0">
+                <a:solidFill>
+                  <a:srgbClr val="1E293B"/>
+                </a:solidFill>
+                <a:latin typeface="Calibri" pitchFamily="34" charset="0"/>
+                <a:ea typeface="Calibri" pitchFamily="34" charset="-122"/>
+                <a:cs typeface="Calibri" pitchFamily="34" charset="-120"/>
+              </a:rPr>
+              <a:t>sf-develop</a:t>
             </a:r>
             <a:endParaRPr lang="en-US" sz="1100" dirty="0"/>
           </a:p>
@@ -24000,7 +24017,24 @@
                 <a:ea typeface="Calibri" pitchFamily="34" charset="-122"/>
                 <a:cs typeface="Calibri" pitchFamily="34" charset="-120"/>
               </a:rPr>
-              <a:t>sf-architect-solutioning</a:t>
+              <a:t>sf-architect-solutioning +</a:t>
+            </a:r>
+            <a:endParaRPr lang="en-US" sz="900" dirty="0"/>
+          </a:p>
+          <a:p>
+            <a:pPr marL="0" indent="0" algn="ctr">
+              <a:buNone/>
+            </a:pPr>
+            <a:r>
+              <a:rPr lang="en-US" sz="900" dirty="0">
+                <a:solidFill>
+                  <a:srgbClr val="E2E8F0"/>
+                </a:solidFill>
+                <a:latin typeface="Calibri" pitchFamily="34" charset="0"/>
+                <a:ea typeface="Calibri" pitchFamily="34" charset="-122"/>
+                <a:cs typeface="Calibri" pitchFamily="34" charset="-120"/>
+              </a:rPr>
+              <a:t>sf-develop</a:t>
             </a:r>
             <a:endParaRPr lang="en-US" sz="900" dirty="0"/>
           </a:p>
@@ -32669,6 +32703,24 @@
             <a:r>
               <a:rPr lang="en-US" sz="1000" dirty="0">
                 <a:solidFill>
+                  <a:srgbClr val="0D9488"/>
+                </a:solidFill>
+                <a:latin typeface="Calibri" pitchFamily="34" charset="0"/>
+                <a:ea typeface="Calibri" pitchFamily="34" charset="-122"/>
+                <a:cs typeface="Calibri" pitchFamily="34" charset="-120"/>
+              </a:rPr>
+              <a:t>/sf-develop → build metadata, Apex, tests</a:t>
+            </a:r>
+            <a:endParaRPr lang="en-US" sz="1000" dirty="0"/>
+          </a:p>
+          <a:p>
+            <a:pPr marL="342900" indent="-342900">
+              <a:buSzPct val="100000"/>
+              <a:buChar char="•"/>
+            </a:pPr>
+            <a:r>
+              <a:rPr lang="en-US" sz="1000" dirty="0">
+                <a:solidFill>
                   <a:srgbClr val="1E293B"/>
                 </a:solidFill>
                 <a:latin typeface="Calibri" pitchFamily="34" charset="0"/>
@@ -32888,6 +32940,24 @@
                 <a:cs typeface="Calibri" pitchFamily="34" charset="-120"/>
               </a:rPr>
               <a:t>/sf-architect-solutioning → component plan</a:t>
+            </a:r>
+            <a:endParaRPr lang="en-US" sz="1000" dirty="0"/>
+          </a:p>
+          <a:p>
+            <a:pPr marL="342900" indent="-342900">
+              <a:buSzPct val="100000"/>
+              <a:buChar char="•"/>
+            </a:pPr>
+            <a:r>
+              <a:rPr lang="en-US" sz="1000" dirty="0">
+                <a:solidFill>
+                  <a:srgbClr val="0D9488"/>
+                </a:solidFill>
+                <a:latin typeface="Calibri" pitchFamily="34" charset="0"/>
+                <a:ea typeface="Calibri" pitchFamily="34" charset="-122"/>
+                <a:cs typeface="Calibri" pitchFamily="34" charset="-120"/>
+              </a:rPr>
+              <a:t>/sf-develop → build LWC, Apex, tests</a:t>
             </a:r>
             <a:endParaRPr lang="en-US" sz="1000" dirty="0"/>
           </a:p>
@@ -34078,6 +34148,23 @@
             </a:r>
             <a:endParaRPr lang="en-US" sz="1000" dirty="0"/>
           </a:p>
+          <a:p>
+            <a:pPr marL="0" indent="0" algn="ctr">
+              <a:buNone/>
+            </a:pPr>
+            <a:r>
+              <a:rPr lang="en-US" sz="800" dirty="0">
+                <a:solidFill>
+                  <a:srgbClr val="0D9488"/>
+                </a:solidFill>
+                <a:latin typeface="Calibri" pitchFamily="34" charset="0"/>
+                <a:ea typeface="Calibri" pitchFamily="34" charset="-122"/>
+                <a:cs typeface="Calibri" pitchFamily="34" charset="-120"/>
+              </a:rPr>
+              <a:t>(sf-develop)</a:t>
+            </a:r>
+            <a:endParaRPr lang="en-US" sz="800" dirty="0"/>
+          </a:p>
         </p:txBody>
       </p:sp>
       <p:sp>
@@ -36225,7 +36312,7 @@
                 <a:ea typeface="Calibri" pitchFamily="34" charset="-122"/>
                 <a:cs typeface="Calibri" pitchFamily="34" charset="-120"/>
               </a:rPr>
-              <a:t>Copy sf-project-init and sf-architect-solutioning to your Claude Code skills directory</a:t>
+              <a:t>Copy sf-project-init, sf-architect-solutioning, and sf-develop to your Claude Code skills directory</a:t>
             </a:r>
             <a:endParaRPr lang="en-US" sz="1100" dirty="0"/>
           </a:p>
@@ -36657,7 +36744,7 @@
                 <a:ea typeface="Calibri" pitchFamily="34" charset="-122"/>
                 <a:cs typeface="Calibri" pitchFamily="34" charset="-120"/>
               </a:rPr>
-              <a:t>Use /sf-architect-solutioning for each feature before coding</a:t>
+              <a:t>Use /sf-architect-solutioning to plan, then /sf-develop to build</a:t>
             </a:r>
             <a:endParaRPr lang="en-US" sz="1100" dirty="0"/>
           </a:p>
@@ -36968,7 +37055,7 @@
                 <a:ea typeface="Calibri" pitchFamily="34" charset="-122"/>
                 <a:cs typeface="Calibri" pitchFamily="34" charset="-120"/>
               </a:rPr>
-              <a:t>Install skills and configure MCP servers</a:t>
+              <a:t>Install all 3 skills and configure MCP servers</a:t>
             </a:r>
             <a:endParaRPr lang="en-US" sz="1400" dirty="0"/>
           </a:p>
@@ -37421,6 +37508,23 @@
             </a:r>
             <a:endParaRPr lang="en-US" sz="1000" dirty="0"/>
           </a:p>
+          <a:p>
+            <a:pPr marL="0" indent="0" algn="ctr">
+              <a:buNone/>
+            </a:pPr>
+            <a:r>
+              <a:rPr lang="en-US" sz="1000" dirty="0">
+                <a:solidFill>
+                  <a:srgbClr val="0D9488"/>
+                </a:solidFill>
+                <a:latin typeface="Calibri" pitchFamily="34" charset="0"/>
+                <a:ea typeface="Calibri" pitchFamily="34" charset="-122"/>
+                <a:cs typeface="Calibri" pitchFamily="34" charset="-120"/>
+              </a:rPr>
+              <a:t>sf-develop</a:t>
+            </a:r>
+            <a:endParaRPr lang="en-US" sz="1000" dirty="0"/>
+          </a:p>
         </p:txBody>
       </p:sp>
       <p:sp>
@@ -38656,6 +38760,24 @@
                 <a:ea typeface="Calibri" pitchFamily="34" charset="-122"/>
                 <a:cs typeface="Calibri" pitchFamily="34" charset="-120"/>
               </a:rPr>
+              <a:t>sf-develop</a:t>
+            </a:r>
+            <a:endParaRPr lang="en-US" sz="1000" dirty="0"/>
+          </a:p>
+          <a:p>
+            <a:pPr marL="342900" indent="-342900">
+              <a:buSzPct val="100000"/>
+              <a:buChar char="•"/>
+            </a:pPr>
+            <a:r>
+              <a:rPr lang="en-US" sz="1000" dirty="0">
+                <a:solidFill>
+                  <a:srgbClr val="0D9488"/>
+                </a:solidFill>
+                <a:latin typeface="Calibri" pitchFamily="34" charset="0"/>
+                <a:ea typeface="Calibri" pitchFamily="34" charset="-122"/>
+                <a:cs typeface="Calibri" pitchFamily="34" charset="-120"/>
+              </a:rPr>
               <a:t>8 Metadata Ref Templates</a:t>
             </a:r>
             <a:endParaRPr lang="en-US" sz="1000" dirty="0"/>
@@ -40200,7 +40322,7 @@
                 <a:ea typeface="Calibri" pitchFamily="34" charset="-122"/>
                 <a:cs typeface="Calibri" pitchFamily="34" charset="-120"/>
               </a:rPr>
-              <a:t>Generates: </a:t>
+              <a:t xml:space="preserve">Generates: </a:t>
             </a:r>
             <a:r>
               <a:rPr lang="en-US" sz="1200" dirty="0">
@@ -40250,7 +40372,7 @@
                 <a:ea typeface="Calibri" pitchFamily="34" charset="-122"/>
                 <a:cs typeface="Calibri" pitchFamily="34" charset="-120"/>
               </a:rPr>
-              <a:t>Entry Points: </a:t>
+              <a:t xml:space="preserve">Entry Points: </a:t>
             </a:r>
             <a:r>
               <a:rPr lang="en-US" sz="1200" dirty="0">

</xml_diff>